<commit_message>
feat: add ppt_automation script and update .gitignore to exclude common Office document formats
</commit_message>
<xml_diff>
--- a/20260428/진단평가시트_20260428.pptx
+++ b/20260428/진단평가시트_20260428.pptx
@@ -8567,7 +8567,7 @@
         </p:nvSpPr>
         <p:spPr bwMode="auto">
           <a:xfrm>
-            <a:off x="194472" y="757339"/>
+            <a:off x="194472" y="732172"/>
             <a:ext cx="936104" cy="438065"/>
           </a:xfrm>
           <a:prstGeom prst="roundRect">
@@ -8630,14 +8630,14 @@
           <p:nvPr>
             <p:extLst>
               <p:ext uri="{D42A27DB-BD31-4B8C-83A1-F6EECF244321}">
-                <p14:modId xmlns:p14="http://schemas.microsoft.com/office/powerpoint/2010/main" val="1746899307"/>
+                <p14:modId xmlns:p14="http://schemas.microsoft.com/office/powerpoint/2010/main" val="3918430680"/>
               </p:ext>
             </p:extLst>
           </p:nvPr>
         </p:nvGraphicFramePr>
         <p:xfrm>
-          <a:off x="1364601" y="757335"/>
-          <a:ext cx="8112900" cy="1649158"/>
+          <a:off x="1364601" y="732166"/>
+          <a:ext cx="8112900" cy="1649160"/>
         </p:xfrm>
         <a:graphic>
           <a:graphicData uri="http://schemas.openxmlformats.org/drawingml/2006/table">
@@ -8666,7 +8666,7 @@
                   </a:extLst>
                 </a:gridCol>
               </a:tblGrid>
-              <a:tr h="322315">
+              <a:tr h="330864">
                 <a:tc>
                   <a:txBody>
                     <a:bodyPr/>
@@ -8879,8 +8879,35 @@
                           <a:ea typeface="+mn-ea"/>
                           <a:cs typeface="+mn-cs"/>
                         </a:rPr>
-                        <a:t>문항 및 평가기준</a:t>
+                        <a:t>문항 및 </a:t>
                       </a:r>
+                      <a:r>
+                        <a:rPr kumimoji="1" lang="ko-KR" altLang="en-US" sz="900" b="1" i="0" u="none" strike="noStrike" kern="1200" cap="none" normalizeH="0" baseline="0" dirty="0" smtClean="0">
+                          <a:ln>
+                            <a:noFill/>
+                          </a:ln>
+                          <a:solidFill>
+                            <a:schemeClr val="tx1"/>
+                          </a:solidFill>
+                          <a:effectLst/>
+                          <a:latin typeface="+mn-lt"/>
+                          <a:ea typeface="+mn-ea"/>
+                          <a:cs typeface="+mn-cs"/>
+                        </a:rPr>
+                        <a:t>평가 기준</a:t>
+                      </a:r>
+                      <a:endParaRPr kumimoji="1" lang="ko-KR" altLang="en-US" sz="900" b="1" i="0" u="none" strike="noStrike" kern="1200" cap="none" normalizeH="0" baseline="0" dirty="0" smtClean="0">
+                        <a:ln>
+                          <a:noFill/>
+                        </a:ln>
+                        <a:solidFill>
+                          <a:schemeClr val="tx1"/>
+                        </a:solidFill>
+                        <a:effectLst/>
+                        <a:latin typeface="+mn-lt"/>
+                        <a:ea typeface="+mn-ea"/>
+                        <a:cs typeface="+mn-cs"/>
+                      </a:endParaRPr>
                     </a:p>
                   </a:txBody>
                   <a:tcPr marL="0" marR="0" marT="0" marB="0" anchor="ctr" horzOverflow="overflow">
@@ -8940,7 +8967,7 @@
                   </a:ext>
                 </a:extLst>
               </a:tr>
-              <a:tr h="502561">
+              <a:tr h="317973">
                 <a:tc>
                   <a:txBody>
                     <a:bodyPr/>
@@ -9151,7 +9178,7 @@
                     <a:bodyPr/>
                     <a:lstStyle/>
                     <a:p>
-                      <a:pPr marL="0" marR="0" lvl="0" indent="0" algn="ctr" defTabSz="739775" rtl="0" eaLnBrk="0" fontAlgn="base" latinLnBrk="1" hangingPunct="0">
+                      <a:pPr marL="0" marR="0" lvl="0" indent="0" algn="l" defTabSz="739775" rtl="0" eaLnBrk="0" fontAlgn="base" latinLnBrk="1" hangingPunct="0">
                         <a:lnSpc>
                           <a:spcPct val="100000"/>
                         </a:lnSpc>
@@ -9232,7 +9259,7 @@
                       </a:endParaRPr>
                     </a:p>
                   </a:txBody>
-                  <a:tcPr marL="0" marR="0" marT="0" marB="0" anchor="ctr" horzOverflow="overflow">
+                  <a:tcPr marL="72000" marR="0" marT="0" marB="0" anchor="ctr" horzOverflow="overflow">
                     <a:lnL w="3175" cap="flat" cmpd="sng" algn="ctr">
                       <a:solidFill>
                         <a:schemeClr val="tx1"/>
@@ -9284,7 +9311,7 @@
                   </a:ext>
                 </a:extLst>
               </a:tr>
-              <a:tr h="321721">
+              <a:tr h="305644">
                 <a:tc gridSpan="3">
                   <a:txBody>
                     <a:bodyPr/>
@@ -9319,7 +9346,7 @@
                           <a:ea typeface="+mn-ea"/>
                           <a:cs typeface="+mn-cs"/>
                         </a:rPr>
-                        <a:t>재평가 요청 내용</a:t>
+                        <a:t>평가 요청 내용</a:t>
                       </a:r>
                       <a:endParaRPr kumimoji="1" lang="ko-KR" altLang="en-US" sz="900" b="0" i="0" u="none" strike="noStrike" cap="none" normalizeH="0" baseline="0" dirty="0" smtClean="0">
                         <a:ln>
@@ -9551,7 +9578,7 @@
                   </a:ext>
                 </a:extLst>
               </a:tr>
-              <a:tr h="502561">
+              <a:tr h="694679">
                 <a:tc gridSpan="3">
                   <a:txBody>
                     <a:bodyPr/>
@@ -9573,20 +9600,6 @@
                         <a:buNone/>
                         <a:tabLst/>
                       </a:pPr>
-                      <a:r>
-                        <a:rPr kumimoji="1" lang="ko-KR" altLang="en-US" sz="900" b="0" i="0" u="none" strike="noStrike" cap="none" normalizeH="0" baseline="0" dirty="0" smtClean="0">
-                          <a:ln>
-                            <a:noFill/>
-                          </a:ln>
-                          <a:solidFill>
-                            <a:schemeClr val="tx1"/>
-                          </a:solidFill>
-                          <a:effectLst/>
-                          <a:latin typeface="+mn-lt"/>
-                          <a:ea typeface="+mn-ea"/>
-                        </a:rPr>
-                        <a:t>  </a:t>
-                      </a:r>
                       <a:endParaRPr kumimoji="1" lang="en-US" altLang="ko-KR" sz="900" b="0" i="0" u="none" strike="noStrike" cap="none" normalizeH="0" baseline="0" dirty="0" smtClean="0">
                         <a:ln>
                           <a:noFill/>
@@ -9600,7 +9613,7 @@
                       </a:endParaRPr>
                     </a:p>
                   </a:txBody>
-                  <a:tcPr marL="0" marR="0" marT="0" marB="0" anchor="ctr" horzOverflow="overflow">
+                  <a:tcPr marL="72000" marR="0" marT="0" marB="0" anchor="ctr" horzOverflow="overflow">
                     <a:lnL w="3175" cap="flat" cmpd="sng" algn="ctr">
                       <a:solidFill>
                         <a:schemeClr val="tx1"/>
@@ -9825,14 +9838,14 @@
           <p:nvPr>
             <p:extLst>
               <p:ext uri="{D42A27DB-BD31-4B8C-83A1-F6EECF244321}">
-                <p14:modId xmlns:p14="http://schemas.microsoft.com/office/powerpoint/2010/main" val="1816278677"/>
+                <p14:modId xmlns:p14="http://schemas.microsoft.com/office/powerpoint/2010/main" val="36647155"/>
               </p:ext>
             </p:extLst>
           </p:nvPr>
         </p:nvGraphicFramePr>
         <p:xfrm>
-          <a:off x="1309565" y="2443942"/>
-          <a:ext cx="8161677" cy="4353792"/>
+          <a:off x="1364601" y="2406493"/>
+          <a:ext cx="8112900" cy="4416408"/>
         </p:xfrm>
         <a:graphic>
           <a:graphicData uri="http://schemas.openxmlformats.org/drawingml/2006/table">
@@ -9841,7 +9854,7 @@
                 <a:tableStyleId>{5C22544A-7EE6-4342-B048-85BDC9FD1C3A}</a:tableStyleId>
               </a:tblPr>
               <a:tblGrid>
-                <a:gridCol w="8161677">
+                <a:gridCol w="8112900">
                   <a:extLst>
                     <a:ext uri="{9D8B030D-6E8A-4147-A177-3AD203B41FA5}">
                       <a16:colId xmlns:a16="http://schemas.microsoft.com/office/drawing/2014/main" val="20000"/>
@@ -9849,7 +9862,7 @@
                   </a:extLst>
                 </a:gridCol>
               </a:tblGrid>
-              <a:tr h="4353792">
+              <a:tr h="4416408">
                 <a:tc>
                   <a:txBody>
                     <a:bodyPr/>
@@ -9925,7 +9938,7 @@
         </p:nvCxnSpPr>
         <p:spPr>
           <a:xfrm>
-            <a:off x="211976" y="600831"/>
+            <a:off x="211976" y="575664"/>
             <a:ext cx="9253572" cy="0"/>
           </a:xfrm>
           <a:prstGeom prst="line">

</xml_diff>